<commit_message>
Procedure: the six bootstrap poses give a normal spread of about 0.2, computed with the code
Co-Authored-By: Claude Fable 5.1 <noreply@anthropic.com>
Claude-Session: https://claude.ai/code/session_016X9U4SzM2dXD3fEs3wV3Mm
</commit_message>
<xml_diff>
--- a/docs/presentations/registration_test_procedure.pptx
+++ b/docs/presentations/registration_test_procedure.pptx
@@ -122,7 +122,7 @@
   <p:extLst>
     <p:ext uri="{521415D9-36F7-43E2-AB2F-B90AF26B5E84}">
       <p14:sectionLst xmlns:p14="http://schemas.microsoft.com/office/powerpoint/2010/main">
-        <p14:section name="Introduction" id="{642cb22e-f979-0d29-0c6d-36fba2ac5813}">
+        <p14:section name="Introduction" id="{59ec3f54-7a9b-a682-0a0f-f0260a2a7d7f}">
           <p14:sldIdLst>
             <p14:sldId id="256"/>
             <p14:sldId id="257"/>
@@ -131,13 +131,13 @@
             <p14:sldId id="260"/>
           </p14:sldIdLst>
         </p14:section>
-        <p14:section name="Setup" id="{a66490c6-c1ae-005c-11f0-9b05e0c74f8a}">
+        <p14:section name="Setup" id="{7bdc8323-ac30-43df-b740-432420f8560f}">
           <p14:sldIdLst>
             <p14:sldId id="261"/>
             <p14:sldId id="262"/>
           </p14:sldIdLst>
         </p14:section>
-        <p14:section name="Capture" id="{25f8ce3e-bd65-7b4d-bf66-adac07edfe70}">
+        <p14:section name="Capture" id="{2cb5dd85-77cd-7c09-d2b9-b04a1ff37524}">
           <p14:sldIdLst>
             <p14:sldId id="263"/>
             <p14:sldId id="264"/>
@@ -146,13 +146,13 @@
             <p14:sldId id="267"/>
           </p14:sldIdLst>
         </p14:section>
-        <p14:section name="Checks" id="{32432a2a-a843-c818-59b0-a6177b31353c}">
+        <p14:section name="Checks" id="{40b9a029-fe32-74d8-f004-df59196257af}">
           <p14:sldIdLst>
             <p14:sldId id="268"/>
             <p14:sldId id="269"/>
           </p14:sldIdLst>
         </p14:section>
-        <p14:section name="Wrap-up" id="{8bf55d72-9734-bcfe-e3bf-26ad6b36a16d}">
+        <p14:section name="Wrap-up" id="{dde347da-9fae-74a6-2f7b-b497a55489f1}">
           <p14:sldIdLst>
             <p14:sldId id="270"/>
             <p14:sldId id="271"/>
@@ -1706,7 +1706,7 @@
           <a:p>
             <a:r>
               <a:rPr lang="en-US" dirty="0"/>
-              <a:t>The software determines the sensor's exact position from the full capture set; this step only needs a rough position so that the planned poses land inside the field of view and so that the software knows where to look for the board in each capture. Six hand-jogged poses, tilted in four directions and at two distances, are enough; the bootstrap also reports the normal spread of the six, which must reach 0.05 and is about 0.15 with these tilts. The result, boot.json, is read by the plan tool and the check tool. Procedure section 4 gives the steps and the commands; the words it uses for what the software reports, segmentation, plane residual, normal and offset residual, are defined there with figure 2.</a:t>
+              <a:t>The software determines the sensor's exact position from the full capture set; this step only needs a rough position so that the planned poses land inside the field of view and so that the software knows where to look for the board in each capture. Six hand-jogged poses, tilted in four directions and at two distances, are enough; the bootstrap also reports the normal spread of the six, which must reach 0.05 and is about 0.2 with these tilts. The result, boot.json, is read by the plan tool and the check tool. Procedure section 4 gives the steps and the commands; the words it uses for what the software reports, segmentation, plane residual, normal and offset residual, are defined there with figure 2.</a:t>
             </a:r>
             <a:endParaRPr lang="en-US" dirty="0"/>
           </a:p>

</xml_diff>

<commit_message>
Interim snapshot: dress rehearsal script and results; procedure and deck updated for its findings
docs/procedures/build/dress_rehearsal.py runs the procedure's whole chain on a synthetic
sensor and robot at full scale; docs/procedures/rehearsal/ holds the last run's summary,
registrations, comparison and report. The procedure now says the analysis reads the
plan to keep held-out poses out of the fit, and adds the small-board-image flag to
section 8; the test deck's checks slide carries it. Decision 18 logged. The analysis
and check tools are being changed to match in the next commit.

Co-Authored-By: Claude Fable 5.1 <noreply@anthropic.com>
Claude-Session: https://claude.ai/code/session_016X9U4SzM2dXD3fEs3wV3Mm
</commit_message>
<xml_diff>
--- a/docs/presentations/registration_test_procedure.pptx
+++ b/docs/presentations/registration_test_procedure.pptx
@@ -122,7 +122,7 @@
   <p:extLst>
     <p:ext uri="{521415D9-36F7-43E2-AB2F-B90AF26B5E84}">
       <p14:sectionLst xmlns:p14="http://schemas.microsoft.com/office/powerpoint/2010/main">
-        <p14:section name="Introduction" id="{59ec3f54-7a9b-a682-0a0f-f0260a2a7d7f}">
+        <p14:section name="Introduction" id="{2838a710-7ea8-c819-7ec6-eb2f96c49e1b}">
           <p14:sldIdLst>
             <p14:sldId id="256"/>
             <p14:sldId id="257"/>
@@ -131,13 +131,13 @@
             <p14:sldId id="260"/>
           </p14:sldIdLst>
         </p14:section>
-        <p14:section name="Setup" id="{7bdc8323-ac30-43df-b740-432420f8560f}">
+        <p14:section name="Setup" id="{4517e5bb-8729-3ac3-7494-df02d3b8ea73}">
           <p14:sldIdLst>
             <p14:sldId id="261"/>
             <p14:sldId id="262"/>
           </p14:sldIdLst>
         </p14:section>
-        <p14:section name="Capture" id="{2cb5dd85-77cd-7c09-d2b9-b04a1ff37524}">
+        <p14:section name="Capture" id="{464a9f6f-83e4-fddc-685a-fbb2c4198615}">
           <p14:sldIdLst>
             <p14:sldId id="263"/>
             <p14:sldId id="264"/>
@@ -146,13 +146,13 @@
             <p14:sldId id="267"/>
           </p14:sldIdLst>
         </p14:section>
-        <p14:section name="Checks" id="{40b9a029-fe32-74d8-f004-df59196257af}">
+        <p14:section name="Checks" id="{cb972421-8a7c-c973-c728-0bde960d54b6}">
           <p14:sldIdLst>
             <p14:sldId id="268"/>
             <p14:sldId id="269"/>
           </p14:sldIdLst>
         </p14:section>
-        <p14:section name="Wrap-up" id="{dde347da-9fae-74a6-2f7b-b497a55489f1}">
+        <p14:section name="Wrap-up" id="{d8e274b5-d57c-b465-6f44-c8b1a76c6135}">
           <p14:sldIdLst>
             <p14:sldId id="270"/>
             <p14:sldId id="271"/>
@@ -1002,7 +1002,7 @@
           <a:p>
             <a:r>
               <a:rPr lang="en-US" dirty="0"/>
-              <a:t>The check tool prints one line per pose and a verdict, and writes a JSON report; its exit code is 0 when nothing is flagged, 1 when something is, and 2 when it cannot read the manifest. It runs on each folder as soon as its captures are complete, while the robot and the board are still set up, because that is when a flagged pose can be re-captured. It also reports the normal spread of the set, which should not fall below 0.05 with the plan's defaults. Section 8 of the procedure lists every flag and what it means. The thresholds are placeholders until the first real session sets them.</a:t>
+              <a:t>The check tool prints one line per pose and a verdict, and writes a JSON report; its exit code is 0 when nothing is flagged, 1 when something is, and 2 when it cannot read the manifest. It runs on each folder as soon as its captures are complete, while the robot and the board are still set up, because that is when a flagged pose can be re-captured. It also reports the normal spread of the set, which should not fall below 0.05 with the plan's defaults. Section 8 of the procedure lists every flag and what it means. The thresholds are placeholders until the first real session sets them. A board image of fewer than 1,000 pixels, typically the far standoff at the largest tilt, gives a noisy plane; the check flags it as too small and suppresses its residual flags, and the right response is to drop the pose from the plan rather than re-capture it. The 1,000 is a placeholder.</a:t>
             </a:r>
             <a:endParaRPr lang="en-US" dirty="0"/>
           </a:p>
@@ -5990,7 +5990,7 @@
                   <a:schemeClr val="tx2"/>
                 </a:solidFill>
               </a:rPr>
-              <a:t>Board not found or cut off</a:t>
+              <a:t>Board not found, cut off or too small</a:t>
             </a:r>
             <a:endParaRPr lang="en-US" sz="1600" dirty="0"/>
           </a:p>
@@ -6007,7 +6007,7 @@
                   <a:schemeClr val="accent1"/>
                 </a:solidFill>
               </a:rPr>
-              <a:t>segmentation failed; valid fraction below 50 percent; mask at the border</a:t>
+              <a:t>segmentation failed; valid fraction below 50 percent; mask at the border; under 1,000 pixels</a:t>
             </a:r>
             <a:endParaRPr lang="en-US" sz="1600" dirty="0"/>
           </a:p>
@@ -6021,7 +6021,7 @@
                   <a:schemeClr val="tx1"/>
                 </a:solidFill>
               </a:rPr>
-              <a:t>Pose copied wrongly, something flat closer than the board, the board outside the field, or exposure</a:t>
+              <a:t>Pose copied wrongly, something flat closer than the board, the board outside the field, or exposure. Too small: the pose is at the sensor's limit; drop it, do not re-capture</a:t>
             </a:r>
             <a:endParaRPr lang="en-US" sz="1600" dirty="0"/>
           </a:p>

</xml_diff>

<commit_message>
Interim snapshot: checks slide carries the small-board-image flag
Co-Authored-By: Claude Fable 5.1 <noreply@anthropic.com>
Claude-Session: https://claude.ai/code/session_016X9U4SzM2dXD3fEs3wV3Mm
</commit_message>
<xml_diff>
--- a/docs/presentations/registration_test_procedure.pptx
+++ b/docs/presentations/registration_test_procedure.pptx
@@ -122,7 +122,7 @@
   <p:extLst>
     <p:ext uri="{521415D9-36F7-43E2-AB2F-B90AF26B5E84}">
       <p14:sectionLst xmlns:p14="http://schemas.microsoft.com/office/powerpoint/2010/main">
-        <p14:section name="Introduction" id="{2838a710-7ea8-c819-7ec6-eb2f96c49e1b}">
+        <p14:section name="Introduction" id="{087c1106-6966-ec04-73ed-8415dc5fc5ff}">
           <p14:sldIdLst>
             <p14:sldId id="256"/>
             <p14:sldId id="257"/>
@@ -131,13 +131,13 @@
             <p14:sldId id="260"/>
           </p14:sldIdLst>
         </p14:section>
-        <p14:section name="Setup" id="{4517e5bb-8729-3ac3-7494-df02d3b8ea73}">
+        <p14:section name="Setup" id="{b802a50b-3f73-7159-80e0-680be0bd36a0}">
           <p14:sldIdLst>
             <p14:sldId id="261"/>
             <p14:sldId id="262"/>
           </p14:sldIdLst>
         </p14:section>
-        <p14:section name="Capture" id="{464a9f6f-83e4-fddc-685a-fbb2c4198615}">
+        <p14:section name="Capture" id="{4db34bf4-0b25-92fc-7a06-e39d5f265e91}">
           <p14:sldIdLst>
             <p14:sldId id="263"/>
             <p14:sldId id="264"/>
@@ -146,13 +146,13 @@
             <p14:sldId id="267"/>
           </p14:sldIdLst>
         </p14:section>
-        <p14:section name="Checks" id="{cb972421-8a7c-c973-c728-0bde960d54b6}">
+        <p14:section name="Checks" id="{2445458f-a406-6d89-f53d-aee46129fbf2}">
           <p14:sldIdLst>
             <p14:sldId id="268"/>
             <p14:sldId id="269"/>
           </p14:sldIdLst>
         </p14:section>
-        <p14:section name="Wrap-up" id="{d8e274b5-d57c-b465-6f44-c8b1a76c6135}">
+        <p14:section name="Wrap-up" id="{bb1e6aa4-e5f2-8c74-19f0-5d7afc596ee7}">
           <p14:sldIdLst>
             <p14:sldId id="270"/>
             <p14:sldId id="271"/>
@@ -5990,7 +5990,7 @@
                   <a:schemeClr val="tx2"/>
                 </a:solidFill>
               </a:rPr>
-              <a:t>Board not found, cut off or too small</a:t>
+              <a:t>Board not found or too small</a:t>
             </a:r>
             <a:endParaRPr lang="en-US" sz="1600" dirty="0"/>
           </a:p>
@@ -6007,7 +6007,7 @@
                   <a:schemeClr val="accent1"/>
                 </a:solidFill>
               </a:rPr>
-              <a:t>segmentation failed; valid fraction below 50 percent; mask at the border; under 1,000 pixels</a:t>
+              <a:t>not found; valid fraction below 50 percent; at the border; under 1,000 pixels</a:t>
             </a:r>
             <a:endParaRPr lang="en-US" sz="1600" dirty="0"/>
           </a:p>
@@ -6021,7 +6021,7 @@
                   <a:schemeClr val="tx1"/>
                 </a:solidFill>
               </a:rPr>
-              <a:t>Pose copied wrongly, something flat closer than the board, the board outside the field, or exposure. Too small: the pose is at the sensor's limit; drop it, do not re-capture</a:t>
+              <a:t>Copied wrongly, something flat closer than the board, out of the field, or exposure. Too small: drop the pose</a:t>
             </a:r>
             <a:endParaRPr lang="en-US" sz="1600" dirty="0"/>
           </a:p>

</xml_diff>